<commit_message>
Presentation: added language indicator next to each piece of code
</commit_message>
<xml_diff>
--- a/tese/presentation/Ap Tese.pptx
+++ b/tese/presentation/Ap Tese.pptx
@@ -5076,6 +5076,71 @@
           </a:p>
         </p:txBody>
       </p:sp>
+      <p:sp>
+        <p:nvSpPr>
+          <p:cNvPr id="3" name="TextBox 2">
+            <a:extLst>
+              <a:ext uri="{FF2B5EF4-FFF2-40B4-BE49-F238E27FC236}">
+                <a16:creationId xmlns:a16="http://schemas.microsoft.com/office/drawing/2014/main" id="{C597DA71-1273-3210-1C7F-FE0FBEECE553}"/>
+              </a:ext>
+            </a:extLst>
+          </p:cNvPr>
+          <p:cNvSpPr txBox="1"/>
+          <p:nvPr/>
+        </p:nvSpPr>
+        <p:spPr>
+          <a:xfrm>
+            <a:off x="7526361" y="1671484"/>
+            <a:ext cx="988989" cy="369332"/>
+          </a:xfrm>
+          <a:prstGeom prst="rect">
+            <a:avLst/>
+          </a:prstGeom>
+          <a:solidFill>
+            <a:schemeClr val="accent2">
+              <a:alpha val="50000"/>
+            </a:schemeClr>
+          </a:solidFill>
+          <a:ln>
+            <a:noFill/>
+          </a:ln>
+        </p:spPr>
+        <p:style>
+          <a:lnRef idx="0">
+            <a:scrgbClr r="0" g="0" b="0"/>
+          </a:lnRef>
+          <a:fillRef idx="0">
+            <a:scrgbClr r="0" g="0" b="0"/>
+          </a:fillRef>
+          <a:effectRef idx="0">
+            <a:scrgbClr r="0" g="0" b="0"/>
+          </a:effectRef>
+          <a:fontRef idx="minor">
+            <a:schemeClr val="lt1"/>
+          </a:fontRef>
+        </p:style>
+        <p:txBody>
+          <a:bodyPr wrap="none" rtlCol="0">
+            <a:spAutoFit/>
+          </a:bodyPr>
+          <a:lstStyle/>
+          <a:p>
+            <a:r>
+              <a:rPr lang="pt-PT" i="1" dirty="0" err="1">
+                <a:solidFill>
+                  <a:srgbClr val="002060"/>
+                </a:solidFill>
+              </a:rPr>
+              <a:t>BipLang</a:t>
+            </a:r>
+            <a:endParaRPr lang="en-US" sz="2000" i="1" dirty="0">
+              <a:solidFill>
+                <a:srgbClr val="002060"/>
+              </a:solidFill>
+            </a:endParaRPr>
+          </a:p>
+        </p:txBody>
+      </p:sp>
     </p:spTree>
     <p:extLst>
       <p:ext uri="{BB962C8B-B14F-4D97-AF65-F5344CB8AC3E}">
@@ -5677,6 +5742,71 @@
           </a:p>
         </p:txBody>
       </p:sp>
+      <p:sp>
+        <p:nvSpPr>
+          <p:cNvPr id="8" name="TextBox 7">
+            <a:extLst>
+              <a:ext uri="{FF2B5EF4-FFF2-40B4-BE49-F238E27FC236}">
+                <a16:creationId xmlns:a16="http://schemas.microsoft.com/office/drawing/2014/main" id="{D2A91A72-6BB0-119F-C9A9-00CA1375CDD9}"/>
+              </a:ext>
+            </a:extLst>
+          </p:cNvPr>
+          <p:cNvSpPr txBox="1"/>
+          <p:nvPr/>
+        </p:nvSpPr>
+        <p:spPr>
+          <a:xfrm>
+            <a:off x="7622157" y="1655982"/>
+            <a:ext cx="893193" cy="369332"/>
+          </a:xfrm>
+          <a:prstGeom prst="rect">
+            <a:avLst/>
+          </a:prstGeom>
+          <a:solidFill>
+            <a:schemeClr val="accent2">
+              <a:alpha val="50000"/>
+            </a:schemeClr>
+          </a:solidFill>
+          <a:ln>
+            <a:noFill/>
+          </a:ln>
+        </p:spPr>
+        <p:style>
+          <a:lnRef idx="0">
+            <a:scrgbClr r="0" g="0" b="0"/>
+          </a:lnRef>
+          <a:fillRef idx="0">
+            <a:scrgbClr r="0" g="0" b="0"/>
+          </a:fillRef>
+          <a:effectRef idx="0">
+            <a:scrgbClr r="0" g="0" b="0"/>
+          </a:effectRef>
+          <a:fontRef idx="minor">
+            <a:schemeClr val="lt1"/>
+          </a:fontRef>
+        </p:style>
+        <p:txBody>
+          <a:bodyPr wrap="none" rtlCol="0">
+            <a:spAutoFit/>
+          </a:bodyPr>
+          <a:lstStyle/>
+          <a:p>
+            <a:r>
+              <a:rPr lang="pt-PT" i="1" dirty="0" err="1">
+                <a:solidFill>
+                  <a:srgbClr val="002060"/>
+                </a:solidFill>
+              </a:rPr>
+              <a:t>OCaml</a:t>
+            </a:r>
+            <a:endParaRPr lang="en-US" sz="2000" i="1" dirty="0">
+              <a:solidFill>
+                <a:srgbClr val="002060"/>
+              </a:solidFill>
+            </a:endParaRPr>
+          </a:p>
+        </p:txBody>
+      </p:sp>
     </p:spTree>
     <p:extLst>
       <p:ext uri="{BB962C8B-B14F-4D97-AF65-F5344CB8AC3E}">
@@ -6465,6 +6595,71 @@
           </a:p>
         </p:txBody>
       </p:sp>
+      <p:sp>
+        <p:nvSpPr>
+          <p:cNvPr id="6" name="TextBox 5">
+            <a:extLst>
+              <a:ext uri="{FF2B5EF4-FFF2-40B4-BE49-F238E27FC236}">
+                <a16:creationId xmlns:a16="http://schemas.microsoft.com/office/drawing/2014/main" id="{472D775F-0CDD-6342-FD8A-53E4ACA2EF82}"/>
+              </a:ext>
+            </a:extLst>
+          </p:cNvPr>
+          <p:cNvSpPr txBox="1"/>
+          <p:nvPr/>
+        </p:nvSpPr>
+        <p:spPr>
+          <a:xfrm>
+            <a:off x="5675340" y="4769081"/>
+            <a:ext cx="988989" cy="369332"/>
+          </a:xfrm>
+          <a:prstGeom prst="rect">
+            <a:avLst/>
+          </a:prstGeom>
+          <a:solidFill>
+            <a:schemeClr val="accent2">
+              <a:alpha val="50000"/>
+            </a:schemeClr>
+          </a:solidFill>
+          <a:ln>
+            <a:noFill/>
+          </a:ln>
+        </p:spPr>
+        <p:style>
+          <a:lnRef idx="0">
+            <a:scrgbClr r="0" g="0" b="0"/>
+          </a:lnRef>
+          <a:fillRef idx="0">
+            <a:scrgbClr r="0" g="0" b="0"/>
+          </a:fillRef>
+          <a:effectRef idx="0">
+            <a:scrgbClr r="0" g="0" b="0"/>
+          </a:effectRef>
+          <a:fontRef idx="minor">
+            <a:schemeClr val="lt1"/>
+          </a:fontRef>
+        </p:style>
+        <p:txBody>
+          <a:bodyPr wrap="none" rtlCol="0">
+            <a:spAutoFit/>
+          </a:bodyPr>
+          <a:lstStyle/>
+          <a:p>
+            <a:r>
+              <a:rPr lang="pt-PT" i="1" dirty="0" err="1">
+                <a:solidFill>
+                  <a:srgbClr val="002060"/>
+                </a:solidFill>
+              </a:rPr>
+              <a:t>BipLang</a:t>
+            </a:r>
+            <a:endParaRPr lang="en-US" sz="2000" i="1" dirty="0">
+              <a:solidFill>
+                <a:srgbClr val="002060"/>
+              </a:solidFill>
+            </a:endParaRPr>
+          </a:p>
+        </p:txBody>
+      </p:sp>
     </p:spTree>
     <p:extLst>
       <p:ext uri="{BB962C8B-B14F-4D97-AF65-F5344CB8AC3E}">
@@ -6869,6 +7064,71 @@
           <a:p>
             <a:pPr lvl="1"/>
             <a:endParaRPr lang="en-US" sz="1600" dirty="0"/>
+          </a:p>
+        </p:txBody>
+      </p:sp>
+      <p:sp>
+        <p:nvSpPr>
+          <p:cNvPr id="6" name="TextBox 5">
+            <a:extLst>
+              <a:ext uri="{FF2B5EF4-FFF2-40B4-BE49-F238E27FC236}">
+                <a16:creationId xmlns:a16="http://schemas.microsoft.com/office/drawing/2014/main" id="{3C3BBAB1-9BB1-87AE-7136-C7FFB1C9E165}"/>
+              </a:ext>
+            </a:extLst>
+          </p:cNvPr>
+          <p:cNvSpPr txBox="1"/>
+          <p:nvPr/>
+        </p:nvSpPr>
+        <p:spPr>
+          <a:xfrm>
+            <a:off x="5848592" y="4766089"/>
+            <a:ext cx="988989" cy="369332"/>
+          </a:xfrm>
+          <a:prstGeom prst="rect">
+            <a:avLst/>
+          </a:prstGeom>
+          <a:solidFill>
+            <a:schemeClr val="accent2">
+              <a:alpha val="50000"/>
+            </a:schemeClr>
+          </a:solidFill>
+          <a:ln>
+            <a:noFill/>
+          </a:ln>
+        </p:spPr>
+        <p:style>
+          <a:lnRef idx="0">
+            <a:scrgbClr r="0" g="0" b="0"/>
+          </a:lnRef>
+          <a:fillRef idx="0">
+            <a:scrgbClr r="0" g="0" b="0"/>
+          </a:fillRef>
+          <a:effectRef idx="0">
+            <a:scrgbClr r="0" g="0" b="0"/>
+          </a:effectRef>
+          <a:fontRef idx="minor">
+            <a:schemeClr val="lt1"/>
+          </a:fontRef>
+        </p:style>
+        <p:txBody>
+          <a:bodyPr wrap="none" rtlCol="0">
+            <a:spAutoFit/>
+          </a:bodyPr>
+          <a:lstStyle/>
+          <a:p>
+            <a:r>
+              <a:rPr lang="pt-PT" i="1" dirty="0" err="1">
+                <a:solidFill>
+                  <a:srgbClr val="002060"/>
+                </a:solidFill>
+              </a:rPr>
+              <a:t>BipLang</a:t>
+            </a:r>
+            <a:endParaRPr lang="en-US" sz="2000" i="1" dirty="0">
+              <a:solidFill>
+                <a:srgbClr val="002060"/>
+              </a:solidFill>
+            </a:endParaRPr>
           </a:p>
         </p:txBody>
       </p:sp>
@@ -7939,6 +8199,71 @@
               <a:t> *)</a:t>
             </a:r>
             <a:endParaRPr lang="en-US" sz="1600" dirty="0"/>
+          </a:p>
+        </p:txBody>
+      </p:sp>
+      <p:sp>
+        <p:nvSpPr>
+          <p:cNvPr id="6" name="TextBox 5">
+            <a:extLst>
+              <a:ext uri="{FF2B5EF4-FFF2-40B4-BE49-F238E27FC236}">
+                <a16:creationId xmlns:a16="http://schemas.microsoft.com/office/drawing/2014/main" id="{838FCAC9-C901-F459-CCA7-1F7718B712A7}"/>
+              </a:ext>
+            </a:extLst>
+          </p:cNvPr>
+          <p:cNvSpPr txBox="1"/>
+          <p:nvPr/>
+        </p:nvSpPr>
+        <p:spPr>
+          <a:xfrm>
+            <a:off x="7081879" y="4479437"/>
+            <a:ext cx="988989" cy="369332"/>
+          </a:xfrm>
+          <a:prstGeom prst="rect">
+            <a:avLst/>
+          </a:prstGeom>
+          <a:solidFill>
+            <a:schemeClr val="accent2">
+              <a:alpha val="50000"/>
+            </a:schemeClr>
+          </a:solidFill>
+          <a:ln>
+            <a:noFill/>
+          </a:ln>
+        </p:spPr>
+        <p:style>
+          <a:lnRef idx="0">
+            <a:scrgbClr r="0" g="0" b="0"/>
+          </a:lnRef>
+          <a:fillRef idx="0">
+            <a:scrgbClr r="0" g="0" b="0"/>
+          </a:fillRef>
+          <a:effectRef idx="0">
+            <a:scrgbClr r="0" g="0" b="0"/>
+          </a:effectRef>
+          <a:fontRef idx="minor">
+            <a:schemeClr val="lt1"/>
+          </a:fontRef>
+        </p:style>
+        <p:txBody>
+          <a:bodyPr wrap="none" rtlCol="0">
+            <a:spAutoFit/>
+          </a:bodyPr>
+          <a:lstStyle/>
+          <a:p>
+            <a:r>
+              <a:rPr lang="pt-PT" i="1" dirty="0" err="1">
+                <a:solidFill>
+                  <a:srgbClr val="002060"/>
+                </a:solidFill>
+              </a:rPr>
+              <a:t>BipLang</a:t>
+            </a:r>
+            <a:endParaRPr lang="en-US" sz="2000" i="1" dirty="0">
+              <a:solidFill>
+                <a:srgbClr val="002060"/>
+              </a:solidFill>
+            </a:endParaRPr>
           </a:p>
         </p:txBody>
       </p:sp>
@@ -9173,6 +9498,71 @@
           </a:p>
         </p:txBody>
       </p:sp>
+      <p:sp>
+        <p:nvSpPr>
+          <p:cNvPr id="7" name="TextBox 6">
+            <a:extLst>
+              <a:ext uri="{FF2B5EF4-FFF2-40B4-BE49-F238E27FC236}">
+                <a16:creationId xmlns:a16="http://schemas.microsoft.com/office/drawing/2014/main" id="{47FC79D1-0BBA-9A75-2C5C-88391008E030}"/>
+              </a:ext>
+            </a:extLst>
+          </p:cNvPr>
+          <p:cNvSpPr txBox="1"/>
+          <p:nvPr/>
+        </p:nvSpPr>
+        <p:spPr>
+          <a:xfrm>
+            <a:off x="7421762" y="4321877"/>
+            <a:ext cx="893193" cy="369332"/>
+          </a:xfrm>
+          <a:prstGeom prst="rect">
+            <a:avLst/>
+          </a:prstGeom>
+          <a:solidFill>
+            <a:schemeClr val="accent2">
+              <a:alpha val="50000"/>
+            </a:schemeClr>
+          </a:solidFill>
+          <a:ln>
+            <a:noFill/>
+          </a:ln>
+        </p:spPr>
+        <p:style>
+          <a:lnRef idx="0">
+            <a:scrgbClr r="0" g="0" b="0"/>
+          </a:lnRef>
+          <a:fillRef idx="0">
+            <a:scrgbClr r="0" g="0" b="0"/>
+          </a:fillRef>
+          <a:effectRef idx="0">
+            <a:scrgbClr r="0" g="0" b="0"/>
+          </a:effectRef>
+          <a:fontRef idx="minor">
+            <a:schemeClr val="lt1"/>
+          </a:fontRef>
+        </p:style>
+        <p:txBody>
+          <a:bodyPr wrap="none" rtlCol="0">
+            <a:spAutoFit/>
+          </a:bodyPr>
+          <a:lstStyle/>
+          <a:p>
+            <a:r>
+              <a:rPr lang="pt-PT" i="1" dirty="0" err="1">
+                <a:solidFill>
+                  <a:srgbClr val="002060"/>
+                </a:solidFill>
+              </a:rPr>
+              <a:t>OCaml</a:t>
+            </a:r>
+            <a:endParaRPr lang="en-US" sz="2000" i="1" dirty="0">
+              <a:solidFill>
+                <a:srgbClr val="002060"/>
+              </a:solidFill>
+            </a:endParaRPr>
+          </a:p>
+        </p:txBody>
+      </p:sp>
     </p:spTree>
     <p:extLst>
       <p:ext uri="{BB962C8B-B14F-4D97-AF65-F5344CB8AC3E}">
@@ -9887,6 +10277,71 @@
               <a:t> *)</a:t>
             </a:r>
             <a:endParaRPr lang="en-US" sz="1600" dirty="0"/>
+          </a:p>
+        </p:txBody>
+      </p:sp>
+      <p:sp>
+        <p:nvSpPr>
+          <p:cNvPr id="7" name="TextBox 6">
+            <a:extLst>
+              <a:ext uri="{FF2B5EF4-FFF2-40B4-BE49-F238E27FC236}">
+                <a16:creationId xmlns:a16="http://schemas.microsoft.com/office/drawing/2014/main" id="{ABA848BC-854F-4F5E-1390-34D1893D54A5}"/>
+              </a:ext>
+            </a:extLst>
+          </p:cNvPr>
+          <p:cNvSpPr txBox="1"/>
+          <p:nvPr/>
+        </p:nvSpPr>
+        <p:spPr>
+          <a:xfrm>
+            <a:off x="7486650" y="1936811"/>
+            <a:ext cx="893193" cy="369332"/>
+          </a:xfrm>
+          <a:prstGeom prst="rect">
+            <a:avLst/>
+          </a:prstGeom>
+          <a:solidFill>
+            <a:schemeClr val="accent2">
+              <a:alpha val="50000"/>
+            </a:schemeClr>
+          </a:solidFill>
+          <a:ln>
+            <a:noFill/>
+          </a:ln>
+        </p:spPr>
+        <p:style>
+          <a:lnRef idx="0">
+            <a:scrgbClr r="0" g="0" b="0"/>
+          </a:lnRef>
+          <a:fillRef idx="0">
+            <a:scrgbClr r="0" g="0" b="0"/>
+          </a:fillRef>
+          <a:effectRef idx="0">
+            <a:scrgbClr r="0" g="0" b="0"/>
+          </a:effectRef>
+          <a:fontRef idx="minor">
+            <a:schemeClr val="lt1"/>
+          </a:fontRef>
+        </p:style>
+        <p:txBody>
+          <a:bodyPr wrap="none" rtlCol="0">
+            <a:spAutoFit/>
+          </a:bodyPr>
+          <a:lstStyle/>
+          <a:p>
+            <a:r>
+              <a:rPr lang="pt-PT" i="1" dirty="0" err="1">
+                <a:solidFill>
+                  <a:srgbClr val="002060"/>
+                </a:solidFill>
+              </a:rPr>
+              <a:t>OCaml</a:t>
+            </a:r>
+            <a:endParaRPr lang="en-US" sz="2000" i="1" dirty="0">
+              <a:solidFill>
+                <a:srgbClr val="002060"/>
+              </a:solidFill>
+            </a:endParaRPr>
           </a:p>
         </p:txBody>
       </p:sp>

</xml_diff>

<commit_message>
Revised chapters 1, 2 and 6 grammar
</commit_message>
<xml_diff>
--- a/tese/presentation/Ap Tese.pptx
+++ b/tese/presentation/Ap Tese.pptx
@@ -224,7 +224,7 @@
           <a:p>
             <a:fld id="{374D7271-F55A-4686-93D9-9528AEDA1906}" type="datetimeFigureOut">
               <a:rPr lang="en-US" smtClean="0"/>
-              <a:t>12/13/2025</a:t>
+              <a:t>12/15/2025</a:t>
             </a:fld>
             <a:endParaRPr lang="en-US"/>
           </a:p>
@@ -535,29 +535,6 @@
           <a:bodyPr/>
           <a:lstStyle/>
           <a:p>
-            <a:r>
-              <a:rPr lang="pt-PT" dirty="0"/>
-              <a:t>Todos nós já passámos por situações em que percebemos um erro nalgum tipo de software, seja um site, aplicação ou jogo.</a:t>
-            </a:r>
-          </a:p>
-          <a:p>
-            <a:r>
-              <a:rPr lang="pt-PT" dirty="0"/>
-              <a:t>Alguns destes casos incluem, por exemplo, bugs irritantes num jogo que nos fazem perder uma partida ou problemas em aplicações de entrega de comida ao domicílio que nos fazem ficar sem almoço ou que, pelo menos, este demore mais tempo a chegar.</a:t>
-            </a:r>
-          </a:p>
-          <a:p>
-            <a:r>
-              <a:rPr lang="pt-PT" dirty="0"/>
-              <a:t>No entanto, nenhuma destas situações é comparável a casos em que erros de software levam a perda de vidas humanas ou </a:t>
-            </a:r>
-            <a:r>
-              <a:rPr lang="pt-PT"/>
-              <a:t>expressivos danos económicos.</a:t>
-            </a:r>
-            <a:endParaRPr lang="pt-PT" dirty="0"/>
-          </a:p>
-          <a:p>
             <a:endParaRPr lang="en-US" dirty="0"/>
           </a:p>
         </p:txBody>
@@ -579,7 +556,7 @@
           <a:p>
             <a:fld id="{0B3F2602-38FE-4418-A7EF-ADB22DAE42F9}" type="slidenum">
               <a:rPr lang="en-US" smtClean="0"/>
-              <a:t>2</a:t>
+              <a:t>1</a:t>
             </a:fld>
             <a:endParaRPr lang="en-US"/>
           </a:p>
@@ -588,7 +565,7 @@
     </p:spTree>
     <p:extLst>
       <p:ext uri="{BB962C8B-B14F-4D97-AF65-F5344CB8AC3E}">
-        <p14:creationId xmlns:p14="http://schemas.microsoft.com/office/powerpoint/2010/main" val="938671169"/>
+        <p14:creationId xmlns:p14="http://schemas.microsoft.com/office/powerpoint/2010/main" val="662206208"/>
       </p:ext>
     </p:extLst>
   </p:cSld>
@@ -643,113 +620,29 @@
           <a:lstStyle/>
           <a:p>
             <a:r>
-              <a:rPr lang="en-US" dirty="0"/>
-              <a:t>Quando </a:t>
-            </a:r>
-            <a:r>
-              <a:rPr lang="en-US" dirty="0" err="1"/>
-              <a:t>falamos</a:t>
-            </a:r>
-            <a:r>
-              <a:rPr lang="en-US" dirty="0"/>
-              <a:t> </a:t>
-            </a:r>
-            <a:r>
-              <a:rPr lang="en-US" dirty="0" err="1"/>
-              <a:t>em</a:t>
-            </a:r>
-            <a:r>
-              <a:rPr lang="en-US" dirty="0"/>
-              <a:t> </a:t>
-            </a:r>
-            <a:r>
-              <a:rPr lang="en-US" dirty="0" err="1"/>
-              <a:t>prova</a:t>
-            </a:r>
-            <a:r>
-              <a:rPr lang="en-US" dirty="0"/>
-              <a:t> </a:t>
-            </a:r>
-            <a:r>
-              <a:rPr lang="en-US" dirty="0" err="1"/>
-              <a:t>automática</a:t>
-            </a:r>
-            <a:r>
-              <a:rPr lang="en-US" dirty="0"/>
-              <a:t> de </a:t>
-            </a:r>
-            <a:r>
-              <a:rPr lang="en-US" dirty="0" err="1"/>
-              <a:t>equivalência</a:t>
-            </a:r>
-            <a:r>
-              <a:rPr lang="en-US" dirty="0"/>
-              <a:t>, </a:t>
-            </a:r>
-            <a:r>
-              <a:rPr lang="en-US" dirty="0" err="1"/>
-              <a:t>queremos</a:t>
-            </a:r>
-            <a:r>
-              <a:rPr lang="en-US" dirty="0"/>
-              <a:t> </a:t>
-            </a:r>
-            <a:r>
-              <a:rPr lang="en-US" dirty="0" err="1"/>
-              <a:t>dizer</a:t>
-            </a:r>
-            <a:r>
-              <a:rPr lang="en-US" dirty="0"/>
-              <a:t> </a:t>
-            </a:r>
-            <a:r>
-              <a:rPr lang="en-US" dirty="0" err="1"/>
-              <a:t>sem</a:t>
-            </a:r>
-            <a:r>
-              <a:rPr lang="en-US" dirty="0"/>
-              <a:t> </a:t>
-            </a:r>
-            <a:r>
-              <a:rPr lang="en-US" dirty="0" err="1"/>
-              <a:t>interação</a:t>
-            </a:r>
-            <a:r>
-              <a:rPr lang="en-US" dirty="0"/>
-              <a:t> do </a:t>
-            </a:r>
-            <a:r>
-              <a:rPr lang="en-US" dirty="0" err="1"/>
-              <a:t>utilizador</a:t>
-            </a:r>
-            <a:r>
-              <a:rPr lang="en-US" dirty="0"/>
-              <a:t> </a:t>
-            </a:r>
-            <a:r>
-              <a:rPr lang="en-US" dirty="0" err="1"/>
-              <a:t>depois</a:t>
-            </a:r>
-            <a:r>
-              <a:rPr lang="en-US" dirty="0"/>
-              <a:t> da </a:t>
-            </a:r>
-            <a:r>
-              <a:rPr lang="en-US" dirty="0" err="1"/>
-              <a:t>escrita</a:t>
-            </a:r>
-            <a:r>
-              <a:rPr lang="en-US" dirty="0"/>
-              <a:t> da </a:t>
-            </a:r>
-            <a:r>
-              <a:rPr lang="en-US" dirty="0" err="1"/>
-              <a:t>especificação</a:t>
-            </a:r>
-            <a:r>
-              <a:rPr lang="en-US" dirty="0"/>
-              <a:t>.</a:t>
-            </a:r>
+              <a:rPr lang="pt-PT" dirty="0"/>
+              <a:t>Todos nós já passámos por situações em que percebemos um erro nalgum tipo de software, seja um site, aplicação ou jogo.</a:t>
+            </a:r>
+          </a:p>
+          <a:p>
+            <a:r>
+              <a:rPr lang="pt-PT" dirty="0"/>
+              <a:t>Alguns destes casos incluem, por exemplo, bugs irritantes num jogo que nos fazem perder uma partida ou problemas em aplicações de entrega de comida ao domicílio que nos fazem ficar sem almoço ou que, pelo menos, este demore mais tempo a chegar.</a:t>
+            </a:r>
+          </a:p>
+          <a:p>
+            <a:r>
+              <a:rPr lang="pt-PT" dirty="0"/>
+              <a:t>No entanto, nenhuma destas situações é comparável a casos em que erros de software levam a perda de vidas humanas ou </a:t>
+            </a:r>
+            <a:r>
+              <a:rPr lang="pt-PT"/>
+              <a:t>expressivos danos económicos.</a:t>
+            </a:r>
+            <a:endParaRPr lang="pt-PT" dirty="0"/>
+          </a:p>
+          <a:p>
+            <a:endParaRPr lang="en-US" dirty="0"/>
           </a:p>
         </p:txBody>
       </p:sp>
@@ -770,7 +663,7 @@
           <a:p>
             <a:fld id="{0B3F2602-38FE-4418-A7EF-ADB22DAE42F9}" type="slidenum">
               <a:rPr lang="en-US" smtClean="0"/>
-              <a:t>4</a:t>
+              <a:t>2</a:t>
             </a:fld>
             <a:endParaRPr lang="en-US"/>
           </a:p>
@@ -779,7 +672,7 @@
     </p:spTree>
     <p:extLst>
       <p:ext uri="{BB962C8B-B14F-4D97-AF65-F5344CB8AC3E}">
-        <p14:creationId xmlns:p14="http://schemas.microsoft.com/office/powerpoint/2010/main" val="274053569"/>
+        <p14:creationId xmlns:p14="http://schemas.microsoft.com/office/powerpoint/2010/main" val="938671169"/>
       </p:ext>
     </p:extLst>
   </p:cSld>
@@ -833,6 +726,358 @@
           <a:bodyPr/>
           <a:lstStyle/>
           <a:p>
+            <a:r>
+              <a:rPr lang="en-US" dirty="0"/>
+              <a:t>Quando </a:t>
+            </a:r>
+            <a:r>
+              <a:rPr lang="en-US" dirty="0" err="1"/>
+              <a:t>falamos</a:t>
+            </a:r>
+            <a:r>
+              <a:rPr lang="en-US" dirty="0"/>
+              <a:t> </a:t>
+            </a:r>
+            <a:r>
+              <a:rPr lang="en-US" dirty="0" err="1"/>
+              <a:t>em</a:t>
+            </a:r>
+            <a:r>
+              <a:rPr lang="en-US" dirty="0"/>
+              <a:t> </a:t>
+            </a:r>
+            <a:r>
+              <a:rPr lang="en-US" dirty="0" err="1"/>
+              <a:t>prova</a:t>
+            </a:r>
+            <a:r>
+              <a:rPr lang="en-US" dirty="0"/>
+              <a:t> </a:t>
+            </a:r>
+            <a:r>
+              <a:rPr lang="en-US" dirty="0" err="1"/>
+              <a:t>automática</a:t>
+            </a:r>
+            <a:r>
+              <a:rPr lang="en-US" dirty="0"/>
+              <a:t> de </a:t>
+            </a:r>
+            <a:r>
+              <a:rPr lang="en-US" dirty="0" err="1"/>
+              <a:t>equivalência</a:t>
+            </a:r>
+            <a:r>
+              <a:rPr lang="en-US" dirty="0"/>
+              <a:t>, </a:t>
+            </a:r>
+            <a:r>
+              <a:rPr lang="en-US" dirty="0" err="1"/>
+              <a:t>queremos</a:t>
+            </a:r>
+            <a:r>
+              <a:rPr lang="en-US" dirty="0"/>
+              <a:t> </a:t>
+            </a:r>
+            <a:r>
+              <a:rPr lang="en-US" dirty="0" err="1"/>
+              <a:t>dizer</a:t>
+            </a:r>
+            <a:r>
+              <a:rPr lang="en-US" dirty="0"/>
+              <a:t> </a:t>
+            </a:r>
+            <a:r>
+              <a:rPr lang="en-US" dirty="0" err="1"/>
+              <a:t>sem</a:t>
+            </a:r>
+            <a:r>
+              <a:rPr lang="en-US" dirty="0"/>
+              <a:t> </a:t>
+            </a:r>
+            <a:r>
+              <a:rPr lang="en-US" dirty="0" err="1"/>
+              <a:t>interação</a:t>
+            </a:r>
+            <a:r>
+              <a:rPr lang="en-US" dirty="0"/>
+              <a:t> do </a:t>
+            </a:r>
+            <a:r>
+              <a:rPr lang="en-US" dirty="0" err="1"/>
+              <a:t>utilizador</a:t>
+            </a:r>
+            <a:r>
+              <a:rPr lang="en-US" dirty="0"/>
+              <a:t> </a:t>
+            </a:r>
+            <a:r>
+              <a:rPr lang="en-US" dirty="0" err="1"/>
+              <a:t>depois</a:t>
+            </a:r>
+            <a:r>
+              <a:rPr lang="en-US" dirty="0"/>
+              <a:t> da </a:t>
+            </a:r>
+            <a:r>
+              <a:rPr lang="en-US" dirty="0" err="1"/>
+              <a:t>escrita</a:t>
+            </a:r>
+            <a:r>
+              <a:rPr lang="en-US" dirty="0"/>
+              <a:t> da </a:t>
+            </a:r>
+            <a:r>
+              <a:rPr lang="en-US" dirty="0" err="1"/>
+              <a:t>especificação</a:t>
+            </a:r>
+            <a:r>
+              <a:rPr lang="en-US" dirty="0"/>
+              <a:t>.</a:t>
+            </a:r>
+          </a:p>
+        </p:txBody>
+      </p:sp>
+      <p:sp>
+        <p:nvSpPr>
+          <p:cNvPr id="4" name="Slide Number Placeholder 3"/>
+          <p:cNvSpPr>
+            <a:spLocks noGrp="1"/>
+          </p:cNvSpPr>
+          <p:nvPr>
+            <p:ph type="sldNum" sz="quarter" idx="5"/>
+          </p:nvPr>
+        </p:nvSpPr>
+        <p:spPr/>
+        <p:txBody>
+          <a:bodyPr/>
+          <a:lstStyle/>
+          <a:p>
+            <a:fld id="{0B3F2602-38FE-4418-A7EF-ADB22DAE42F9}" type="slidenum">
+              <a:rPr lang="en-US" smtClean="0"/>
+              <a:t>4</a:t>
+            </a:fld>
+            <a:endParaRPr lang="en-US"/>
+          </a:p>
+        </p:txBody>
+      </p:sp>
+    </p:spTree>
+    <p:extLst>
+      <p:ext uri="{BB962C8B-B14F-4D97-AF65-F5344CB8AC3E}">
+        <p14:creationId xmlns:p14="http://schemas.microsoft.com/office/powerpoint/2010/main" val="274053569"/>
+      </p:ext>
+    </p:extLst>
+  </p:cSld>
+  <p:clrMapOvr>
+    <a:masterClrMapping/>
+  </p:clrMapOvr>
+</p:notes>
+</file>
+
+<file path=ppt/notesSlides/notesSlide4.xml><?xml version="1.0" encoding="utf-8"?>
+<p:notes xmlns:a="http://schemas.openxmlformats.org/drawingml/2006/main" xmlns:r="http://schemas.openxmlformats.org/officeDocument/2006/relationships" xmlns:p="http://schemas.openxmlformats.org/presentationml/2006/main">
+  <p:cSld>
+    <p:spTree>
+      <p:nvGrpSpPr>
+        <p:cNvPr id="1" name=""/>
+        <p:cNvGrpSpPr/>
+        <p:nvPr/>
+      </p:nvGrpSpPr>
+      <p:grpSpPr>
+        <a:xfrm>
+          <a:off x="0" y="0"/>
+          <a:ext cx="0" cy="0"/>
+          <a:chOff x="0" y="0"/>
+          <a:chExt cx="0" cy="0"/>
+        </a:xfrm>
+      </p:grpSpPr>
+      <p:sp>
+        <p:nvSpPr>
+          <p:cNvPr id="2" name="Slide Image Placeholder 1"/>
+          <p:cNvSpPr>
+            <a:spLocks noGrp="1" noRot="1" noChangeAspect="1"/>
+          </p:cNvSpPr>
+          <p:nvPr>
+            <p:ph type="sldImg"/>
+          </p:nvPr>
+        </p:nvSpPr>
+        <p:spPr/>
+      </p:sp>
+      <p:sp>
+        <p:nvSpPr>
+          <p:cNvPr id="3" name="Notes Placeholder 2"/>
+          <p:cNvSpPr>
+            <a:spLocks noGrp="1"/>
+          </p:cNvSpPr>
+          <p:nvPr>
+            <p:ph type="body" idx="1"/>
+          </p:nvPr>
+        </p:nvSpPr>
+        <p:spPr/>
+        <p:txBody>
+          <a:bodyPr/>
+          <a:lstStyle/>
+          <a:p>
+            <a:r>
+              <a:rPr lang="pt-PT" dirty="0"/>
+              <a:t>A </a:t>
+            </a:r>
+            <a:r>
+              <a:rPr lang="pt-PT" dirty="0" err="1"/>
+              <a:t>nocao</a:t>
+            </a:r>
+            <a:r>
+              <a:rPr lang="pt-PT" dirty="0"/>
+              <a:t> de equivalência baseia se na ideia de que existem um programa esquerdo e um direito. Existem dois mundos que não se tocam para simularmos dois programas a executar ao mesmo tempo.</a:t>
+            </a:r>
+          </a:p>
+          <a:p>
+            <a:endParaRPr lang="pt-PT" dirty="0"/>
+          </a:p>
+          <a:p>
+            <a:r>
+              <a:rPr lang="pt-PT" dirty="0" err="1"/>
+              <a:t>Floor</a:t>
+            </a:r>
+            <a:r>
+              <a:rPr lang="pt-PT" dirty="0"/>
+              <a:t> divide-se em representações para o lado esquerdo e direito.</a:t>
+            </a:r>
+          </a:p>
+          <a:p>
+            <a:endParaRPr lang="pt-PT" dirty="0"/>
+          </a:p>
+          <a:p>
+            <a:r>
+              <a:rPr lang="pt-PT" dirty="0" err="1"/>
+              <a:t>Pipe</a:t>
+            </a:r>
+            <a:r>
+              <a:rPr lang="pt-PT" dirty="0"/>
+              <a:t>: à esquerda raciocinamos sobre programa esquerdo e à direita sobre programa direito.</a:t>
+            </a:r>
+          </a:p>
+          <a:p>
+            <a:endParaRPr lang="pt-PT" dirty="0"/>
+          </a:p>
+          <a:p>
+            <a:r>
+              <a:rPr lang="pt-PT" dirty="0" err="1"/>
+              <a:t>Parametros</a:t>
+            </a:r>
+            <a:r>
+              <a:rPr lang="pt-PT" dirty="0"/>
+              <a:t>, </a:t>
+            </a:r>
+            <a:r>
+              <a:rPr lang="pt-PT"/>
+              <a:t>tipo de retorno</a:t>
+            </a:r>
+            <a:r>
+              <a:rPr lang="pt-PT" dirty="0"/>
+              <a:t>, </a:t>
+            </a:r>
+            <a:r>
+              <a:rPr lang="pt-PT" dirty="0" err="1"/>
+              <a:t>let</a:t>
+            </a:r>
+            <a:r>
+              <a:rPr lang="pt-PT" dirty="0"/>
+              <a:t> e </a:t>
+            </a:r>
+            <a:r>
+              <a:rPr lang="pt-PT" dirty="0" err="1"/>
+              <a:t>return</a:t>
+            </a:r>
+            <a:r>
+              <a:rPr lang="pt-PT" dirty="0"/>
+              <a:t>.</a:t>
+            </a:r>
+          </a:p>
+          <a:p>
+            <a:endParaRPr lang="en-US" dirty="0"/>
+          </a:p>
+        </p:txBody>
+      </p:sp>
+      <p:sp>
+        <p:nvSpPr>
+          <p:cNvPr id="4" name="Slide Number Placeholder 3"/>
+          <p:cNvSpPr>
+            <a:spLocks noGrp="1"/>
+          </p:cNvSpPr>
+          <p:nvPr>
+            <p:ph type="sldNum" sz="quarter" idx="5"/>
+          </p:nvPr>
+        </p:nvSpPr>
+        <p:spPr/>
+        <p:txBody>
+          <a:bodyPr/>
+          <a:lstStyle/>
+          <a:p>
+            <a:fld id="{0B3F2602-38FE-4418-A7EF-ADB22DAE42F9}" type="slidenum">
+              <a:rPr lang="en-US" smtClean="0"/>
+              <a:t>13</a:t>
+            </a:fld>
+            <a:endParaRPr lang="en-US"/>
+          </a:p>
+        </p:txBody>
+      </p:sp>
+    </p:spTree>
+    <p:extLst>
+      <p:ext uri="{BB962C8B-B14F-4D97-AF65-F5344CB8AC3E}">
+        <p14:creationId xmlns:p14="http://schemas.microsoft.com/office/powerpoint/2010/main" val="2825876661"/>
+      </p:ext>
+    </p:extLst>
+  </p:cSld>
+  <p:clrMapOvr>
+    <a:masterClrMapping/>
+  </p:clrMapOvr>
+</p:notes>
+</file>
+
+<file path=ppt/notesSlides/notesSlide5.xml><?xml version="1.0" encoding="utf-8"?>
+<p:notes xmlns:a="http://schemas.openxmlformats.org/drawingml/2006/main" xmlns:r="http://schemas.openxmlformats.org/officeDocument/2006/relationships" xmlns:p="http://schemas.openxmlformats.org/presentationml/2006/main">
+  <p:cSld>
+    <p:spTree>
+      <p:nvGrpSpPr>
+        <p:cNvPr id="1" name=""/>
+        <p:cNvGrpSpPr/>
+        <p:nvPr/>
+      </p:nvGrpSpPr>
+      <p:grpSpPr>
+        <a:xfrm>
+          <a:off x="0" y="0"/>
+          <a:ext cx="0" cy="0"/>
+          <a:chOff x="0" y="0"/>
+          <a:chExt cx="0" cy="0"/>
+        </a:xfrm>
+      </p:grpSpPr>
+      <p:sp>
+        <p:nvSpPr>
+          <p:cNvPr id="2" name="Slide Image Placeholder 1"/>
+          <p:cNvSpPr>
+            <a:spLocks noGrp="1" noRot="1" noChangeAspect="1"/>
+          </p:cNvSpPr>
+          <p:nvPr>
+            <p:ph type="sldImg"/>
+          </p:nvPr>
+        </p:nvSpPr>
+        <p:spPr/>
+      </p:sp>
+      <p:sp>
+        <p:nvSpPr>
+          <p:cNvPr id="3" name="Notes Placeholder 2"/>
+          <p:cNvSpPr>
+            <a:spLocks noGrp="1"/>
+          </p:cNvSpPr>
+          <p:nvPr>
+            <p:ph type="body" idx="1"/>
+          </p:nvPr>
+        </p:nvSpPr>
+        <p:spPr/>
+        <p:txBody>
+          <a:bodyPr/>
+          <a:lstStyle/>
+          <a:p>
             <a:endParaRPr lang="en-US" dirty="0"/>
           </a:p>
         </p:txBody>
@@ -873,7 +1118,7 @@
 </p:notes>
 </file>
 
-<file path=ppt/notesSlides/notesSlide4.xml><?xml version="1.0" encoding="utf-8"?>
+<file path=ppt/notesSlides/notesSlide6.xml><?xml version="1.0" encoding="utf-8"?>
 <p:notes xmlns:a="http://schemas.openxmlformats.org/drawingml/2006/main" xmlns:r="http://schemas.openxmlformats.org/officeDocument/2006/relationships" xmlns:p="http://schemas.openxmlformats.org/presentationml/2006/main">
   <p:cSld>
     <p:spTree>
@@ -981,7 +1226,7 @@
 </p:notes>
 </file>
 
-<file path=ppt/notesSlides/notesSlide5.xml><?xml version="1.0" encoding="utf-8"?>
+<file path=ppt/notesSlides/notesSlide7.xml><?xml version="1.0" encoding="utf-8"?>
 <p:notes xmlns:a="http://schemas.openxmlformats.org/drawingml/2006/main" xmlns:r="http://schemas.openxmlformats.org/officeDocument/2006/relationships" xmlns:p="http://schemas.openxmlformats.org/presentationml/2006/main">
   <p:cSld>
     <p:spTree>
@@ -1220,7 +1465,7 @@
           <a:p>
             <a:fld id="{1E5BF2F9-84AD-46CB-8486-EB732804F762}" type="datetime1">
               <a:rPr lang="en-US" smtClean="0"/>
-              <a:t>12/13/2025</a:t>
+              <a:t>12/15/2025</a:t>
             </a:fld>
             <a:endParaRPr lang="en-US"/>
           </a:p>
@@ -1399,7 +1644,7 @@
           <a:p>
             <a:fld id="{23618752-90E6-4B57-86C0-C43DD2320A2D}" type="datetime1">
               <a:rPr lang="en-US" smtClean="0"/>
-              <a:t>12/13/2025</a:t>
+              <a:t>12/15/2025</a:t>
             </a:fld>
             <a:endParaRPr lang="en-US"/>
           </a:p>
@@ -1579,7 +1824,7 @@
           <a:p>
             <a:fld id="{85BE5269-252E-4ABC-B047-AD967E98EA5E}" type="datetime1">
               <a:rPr lang="en-US" smtClean="0"/>
-              <a:t>12/13/2025</a:t>
+              <a:t>12/15/2025</a:t>
             </a:fld>
             <a:endParaRPr lang="en-US"/>
           </a:p>
@@ -1749,7 +1994,7 @@
           <a:p>
             <a:fld id="{C4D54784-9B75-4DBC-ACA0-9F51227CD78F}" type="datetime1">
               <a:rPr lang="en-US" smtClean="0"/>
-              <a:t>12/13/2025</a:t>
+              <a:t>12/15/2025</a:t>
             </a:fld>
             <a:endParaRPr lang="en-US"/>
           </a:p>
@@ -1995,7 +2240,7 @@
           <a:p>
             <a:fld id="{3D9E4D52-32DE-4F35-8CB6-5A44573D3FC9}" type="datetime1">
               <a:rPr lang="en-US" smtClean="0"/>
-              <a:t>12/13/2025</a:t>
+              <a:t>12/15/2025</a:t>
             </a:fld>
             <a:endParaRPr lang="en-US"/>
           </a:p>
@@ -2227,7 +2472,7 @@
           <a:p>
             <a:fld id="{D0FFB22E-8A21-4AF6-BDE0-993A2F9B14BB}" type="datetime1">
               <a:rPr lang="en-US" smtClean="0"/>
-              <a:t>12/13/2025</a:t>
+              <a:t>12/15/2025</a:t>
             </a:fld>
             <a:endParaRPr lang="en-US"/>
           </a:p>
@@ -2594,7 +2839,7 @@
           <a:p>
             <a:fld id="{AC41D9E4-527D-47F1-B47F-963D62CCBC76}" type="datetime1">
               <a:rPr lang="en-US" smtClean="0"/>
-              <a:t>12/13/2025</a:t>
+              <a:t>12/15/2025</a:t>
             </a:fld>
             <a:endParaRPr lang="en-US"/>
           </a:p>
@@ -2712,7 +2957,7 @@
           <a:p>
             <a:fld id="{9906A608-925A-4874-BCA4-36BA40FADF76}" type="datetime1">
               <a:rPr lang="en-US" smtClean="0"/>
-              <a:t>12/13/2025</a:t>
+              <a:t>12/15/2025</a:t>
             </a:fld>
             <a:endParaRPr lang="en-US"/>
           </a:p>
@@ -2807,7 +3052,7 @@
           <a:p>
             <a:fld id="{45CCB426-3683-4E7C-B869-5155B20F8BC6}" type="datetime1">
               <a:rPr lang="en-US" smtClean="0"/>
-              <a:t>12/13/2025</a:t>
+              <a:t>12/15/2025</a:t>
             </a:fld>
             <a:endParaRPr lang="en-US"/>
           </a:p>
@@ -3084,7 +3329,7 @@
           <a:p>
             <a:fld id="{3351EA60-24F6-40E8-A0D7-2067F6ECA6B2}" type="datetime1">
               <a:rPr lang="en-US" smtClean="0"/>
-              <a:t>12/13/2025</a:t>
+              <a:t>12/15/2025</a:t>
             </a:fld>
             <a:endParaRPr lang="en-US"/>
           </a:p>
@@ -3341,7 +3586,7 @@
           <a:p>
             <a:fld id="{C6106440-8C5F-4111-9AD5-D0C1FDF01CE9}" type="datetime1">
               <a:rPr lang="en-US" smtClean="0"/>
-              <a:t>12/13/2025</a:t>
+              <a:t>12/15/2025</a:t>
             </a:fld>
             <a:endParaRPr lang="en-US"/>
           </a:p>
@@ -3557,7 +3802,7 @@
           <a:p>
             <a:fld id="{2A16FEB8-5B01-4F5E-B573-CC516A2AD5E4}" type="datetime1">
               <a:rPr lang="en-US" smtClean="0"/>
-              <a:t>12/13/2025</a:t>
+              <a:t>12/15/2025</a:t>
             </a:fld>
             <a:endParaRPr lang="en-US"/>
           </a:p>

</xml_diff>